<commit_message>
Add SEC-LoRD retrieved-evidence gate readiness
</commit_message>
<xml_diff>
--- a/paper/portfolio_experiment_decks/EXPERIMENT_07_SEC_LORD_REDESIGN_GATE_DECK_20260514.pptx
+++ b/paper/portfolio_experiment_decks/EXPERIMENT_07_SEC_LORD_REDESIGN_GATE_DECK_20260514.pptx
@@ -13,6 +13,7 @@
     <p:sldId id="261" r:id="rId12"/>
     <p:sldId id="262" r:id="rId13"/>
     <p:sldId id="263" r:id="rId14"/>
+    <p:sldId id="264" r:id="rId15"/>
   </p:sldIdLst>
   <p:sldSz cx="12191695" cy="6858000" type="screen4x3"/>
   <p:notesSz cx="6858000" cy="9144000"/>
@@ -3205,7 +3206,7 @@
               </a:defRPr>
             </a:pPr>
             <a:r>
-              <a:t>Current method is negative; redesign gate only</a:t>
+              <a:t>Current method is negative; retrieved-evidence gate is ready</a:t>
             </a:r>
           </a:p>
         </p:txBody>
@@ -3264,7 +3265,19 @@
               </a:defRPr>
             </a:pPr>
             <a:r>
-              <a:t>Decision: no extraction until a retrieved-evidence prompt clears a strict gate.</a:t>
+              <a:t>Prompt gate now exists: 500 CTI-MCQ rows with exact ATT&amp;CK evidence coverage.</a:t>
+            </a:r>
+          </a:p>
+          <a:p>
+            <a:pPr>
+              <a:defRPr sz="2400">
+                <a:solidFill>
+                  <a:srgbClr val="111827"/>
+                </a:solidFill>
+              </a:defRPr>
+            </a:pPr>
+            <a:r>
+              <a:t>Decision: no extraction until the retrieved-evidence prompt clears the strict model gate.</a:t>
             </a:r>
           </a:p>
         </p:txBody>
@@ -4657,6 +4670,425 @@
 </file>
 
 <file path=ppt/slides/slide6.xml><?xml version="1.0" encoding="utf-8"?>
+<p:sld xmlns:a="http://schemas.openxmlformats.org/drawingml/2006/main" xmlns:p="http://schemas.openxmlformats.org/presentationml/2006/main" xmlns:r="http://schemas.openxmlformats.org/officeDocument/2006/relationships">
+  <p:cSld>
+    <p:spTree>
+      <p:nvGrpSpPr>
+        <p:cNvPr id="1" name=""/>
+        <p:cNvGrpSpPr/>
+        <p:nvPr/>
+      </p:nvGrpSpPr>
+      <p:grpSpPr/>
+      <p:sp>
+        <p:nvSpPr>
+          <p:cNvPr id="2" name="TextBox 1"/>
+          <p:cNvSpPr txBox="1"/>
+          <p:nvPr/>
+        </p:nvSpPr>
+        <p:spPr>
+          <a:xfrm>
+            <a:off x="502920" y="292608"/>
+            <a:ext cx="11201400" cy="548640"/>
+          </a:xfrm>
+          <a:prstGeom prst="rect">
+            <a:avLst/>
+          </a:prstGeom>
+          <a:noFill/>
+        </p:spPr>
+        <p:txBody>
+          <a:bodyPr wrap="square">
+            <a:spAutoFit/>
+          </a:bodyPr>
+          <a:lstStyle/>
+          <a:p>
+            <a:pPr>
+              <a:defRPr sz="2800" b="1">
+                <a:solidFill>
+                  <a:srgbClr val="111827"/>
+                </a:solidFill>
+              </a:defRPr>
+            </a:pPr>
+            <a:r>
+              <a:t>Gate Input Is Now Built</a:t>
+            </a:r>
+          </a:p>
+        </p:txBody>
+      </p:sp>
+      <p:sp>
+        <p:nvSpPr>
+          <p:cNvPr id="3" name="Rectangle 2"/>
+          <p:cNvSpPr/>
+          <p:nvPr/>
+        </p:nvSpPr>
+        <p:spPr>
+          <a:xfrm>
+            <a:off x="502920" y="932688"/>
+            <a:ext cx="11109960" cy="32004"/>
+          </a:xfrm>
+          <a:prstGeom prst="rect">
+            <a:avLst/>
+          </a:prstGeom>
+          <a:solidFill>
+            <a:srgbClr val="2563EB"/>
+          </a:solidFill>
+          <a:ln>
+            <a:solidFill>
+              <a:srgbClr val="2563EB"/>
+            </a:solidFill>
+          </a:ln>
+        </p:spPr>
+        <p:style>
+          <a:lnRef idx="1">
+            <a:schemeClr val="accent1"/>
+          </a:lnRef>
+          <a:fillRef idx="3">
+            <a:schemeClr val="accent1"/>
+          </a:fillRef>
+          <a:effectRef idx="2">
+            <a:schemeClr val="accent1"/>
+          </a:effectRef>
+          <a:fontRef idx="minor">
+            <a:schemeClr val="lt1"/>
+          </a:fontRef>
+        </p:style>
+        <p:txBody>
+          <a:bodyPr rtlCol="0" anchor="ctr"/>
+          <a:lstStyle/>
+          <a:p>
+            <a:pPr algn="ctr"/>
+          </a:p>
+        </p:txBody>
+      </p:sp>
+      <p:graphicFrame>
+        <p:nvGraphicFramePr>
+          <p:cNvPr id="4" name="Table 3"/>
+          <p:cNvGraphicFramePr>
+            <a:graphicFrameLocks noGrp="1"/>
+          </p:cNvGraphicFramePr>
+          <p:nvPr/>
+        </p:nvGraphicFramePr>
+        <p:xfrm>
+          <a:off x="685800" y="1417320"/>
+          <a:ext cx="10881360" cy="3291840"/>
+        </p:xfrm>
+        <a:graphic>
+          <a:graphicData uri="http://schemas.openxmlformats.org/drawingml/2006/table">
+            <a:tbl>
+              <a:tblPr firstRow="1" bandRow="1">
+                <a:tableStyleId>{5C22544A-7EE6-4342-B048-85BDC9FD1C3A}</a:tableStyleId>
+              </a:tblPr>
+              <a:tblGrid>
+                <a:gridCol w="5440680"/>
+                <a:gridCol w="5440680"/>
+              </a:tblGrid>
+              <a:tr h="548640">
+                <a:tc>
+                  <a:txBody>
+                    <a:bodyPr/>
+                    <a:lstStyle/>
+                    <a:p>
+                      <a:pPr>
+                        <a:defRPr sz="1600" b="1">
+                          <a:solidFill>
+                            <a:srgbClr val="111827"/>
+                          </a:solidFill>
+                        </a:defRPr>
+                      </a:pPr>
+                      <a:r>
+                        <a:t>Item</a:t>
+                      </a:r>
+                    </a:p>
+                  </a:txBody>
+                  <a:tcPr>
+                    <a:solidFill>
+                      <a:srgbClr val="DBEAFE"/>
+                    </a:solidFill>
+                  </a:tcPr>
+                </a:tc>
+                <a:tc>
+                  <a:txBody>
+                    <a:bodyPr/>
+                    <a:lstStyle/>
+                    <a:p>
+                      <a:pPr>
+                        <a:defRPr sz="1600" b="1">
+                          <a:solidFill>
+                            <a:srgbClr val="111827"/>
+                          </a:solidFill>
+                        </a:defRPr>
+                      </a:pPr>
+                      <a:r>
+                        <a:t>Value</a:t>
+                      </a:r>
+                    </a:p>
+                  </a:txBody>
+                  <a:tcPr>
+                    <a:solidFill>
+                      <a:srgbClr val="DBEAFE"/>
+                    </a:solidFill>
+                  </a:tcPr>
+                </a:tc>
+              </a:tr>
+              <a:tr h="548640">
+                <a:tc>
+                  <a:txBody>
+                    <a:bodyPr/>
+                    <a:lstStyle/>
+                    <a:p>
+                      <a:pPr>
+                        <a:defRPr sz="1600" b="0">
+                          <a:solidFill>
+                            <a:srgbClr val="111827"/>
+                          </a:solidFill>
+                        </a:defRPr>
+                      </a:pPr>
+                      <a:r>
+                        <a:t>CTI-MCQ rows</a:t>
+                      </a:r>
+                    </a:p>
+                  </a:txBody>
+                  <a:tcPr/>
+                </a:tc>
+                <a:tc>
+                  <a:txBody>
+                    <a:bodyPr/>
+                    <a:lstStyle/>
+                    <a:p>
+                      <a:pPr>
+                        <a:defRPr sz="1600" b="0">
+                          <a:solidFill>
+                            <a:srgbClr val="111827"/>
+                          </a:solidFill>
+                        </a:defRPr>
+                      </a:pPr>
+                      <a:r>
+                        <a:t>500</a:t>
+                      </a:r>
+                    </a:p>
+                  </a:txBody>
+                  <a:tcPr/>
+                </a:tc>
+              </a:tr>
+              <a:tr h="548640">
+                <a:tc>
+                  <a:txBody>
+                    <a:bodyPr/>
+                    <a:lstStyle/>
+                    <a:p>
+                      <a:pPr>
+                        <a:defRPr sz="1600" b="0">
+                          <a:solidFill>
+                            <a:srgbClr val="111827"/>
+                          </a:solidFill>
+                        </a:defRPr>
+                      </a:pPr>
+                      <a:r>
+                        <a:t>Rows with exact ATT&amp;CK technique fact</a:t>
+                      </a:r>
+                    </a:p>
+                  </a:txBody>
+                  <a:tcPr/>
+                </a:tc>
+                <a:tc>
+                  <a:txBody>
+                    <a:bodyPr/>
+                    <a:lstStyle/>
+                    <a:p>
+                      <a:pPr>
+                        <a:defRPr sz="1600" b="0">
+                          <a:solidFill>
+                            <a:srgbClr val="111827"/>
+                          </a:solidFill>
+                        </a:defRPr>
+                      </a:pPr>
+                      <a:r>
+                        <a:t>500</a:t>
+                      </a:r>
+                    </a:p>
+                  </a:txBody>
+                  <a:tcPr/>
+                </a:tc>
+              </a:tr>
+              <a:tr h="548640">
+                <a:tc>
+                  <a:txBody>
+                    <a:bodyPr/>
+                    <a:lstStyle/>
+                    <a:p>
+                      <a:pPr>
+                        <a:defRPr sz="1600" b="0">
+                          <a:solidFill>
+                            <a:srgbClr val="111827"/>
+                          </a:solidFill>
+                        </a:defRPr>
+                      </a:pPr>
+                      <a:r>
+                        <a:t>Rows with evidence snippets</a:t>
+                      </a:r>
+                    </a:p>
+                  </a:txBody>
+                  <a:tcPr/>
+                </a:tc>
+                <a:tc>
+                  <a:txBody>
+                    <a:bodyPr/>
+                    <a:lstStyle/>
+                    <a:p>
+                      <a:pPr>
+                        <a:defRPr sz="1600" b="0">
+                          <a:solidFill>
+                            <a:srgbClr val="111827"/>
+                          </a:solidFill>
+                        </a:defRPr>
+                      </a:pPr>
+                      <a:r>
+                        <a:t>500</a:t>
+                      </a:r>
+                    </a:p>
+                  </a:txBody>
+                  <a:tcPr/>
+                </a:tc>
+              </a:tr>
+              <a:tr h="548640">
+                <a:tc>
+                  <a:txBody>
+                    <a:bodyPr/>
+                    <a:lstStyle/>
+                    <a:p>
+                      <a:pPr>
+                        <a:defRPr sz="1600" b="0">
+                          <a:solidFill>
+                            <a:srgbClr val="111827"/>
+                          </a:solidFill>
+                        </a:defRPr>
+                      </a:pPr>
+                      <a:r>
+                        <a:t>Evidence coverage</a:t>
+                      </a:r>
+                    </a:p>
+                  </a:txBody>
+                  <a:tcPr/>
+                </a:tc>
+                <a:tc>
+                  <a:txBody>
+                    <a:bodyPr/>
+                    <a:lstStyle/>
+                    <a:p>
+                      <a:pPr>
+                        <a:defRPr sz="1600" b="0">
+                          <a:solidFill>
+                            <a:srgbClr val="111827"/>
+                          </a:solidFill>
+                        </a:defRPr>
+                      </a:pPr>
+                      <a:r>
+                        <a:t>1.000</a:t>
+                      </a:r>
+                    </a:p>
+                  </a:txBody>
+                  <a:tcPr/>
+                </a:tc>
+              </a:tr>
+              <a:tr h="548640">
+                <a:tc>
+                  <a:txBody>
+                    <a:bodyPr/>
+                    <a:lstStyle/>
+                    <a:p>
+                      <a:pPr>
+                        <a:defRPr sz="1600" b="0">
+                          <a:solidFill>
+                            <a:srgbClr val="111827"/>
+                          </a:solidFill>
+                        </a:defRPr>
+                      </a:pPr>
+                      <a:r>
+                        <a:t>Output format</a:t>
+                      </a:r>
+                    </a:p>
+                  </a:txBody>
+                  <a:tcPr/>
+                </a:tc>
+                <a:tc>
+                  <a:txBody>
+                    <a:bodyPr/>
+                    <a:lstStyle/>
+                    <a:p>
+                      <a:pPr>
+                        <a:defRPr sz="1600" b="0">
+                          <a:solidFill>
+                            <a:srgbClr val="111827"/>
+                          </a:solidFill>
+                        </a:defRPr>
+                      </a:pPr>
+                      <a:r>
+                        <a:t>Answer: &lt;A|B|C|D&gt;</a:t>
+                      </a:r>
+                    </a:p>
+                  </a:txBody>
+                  <a:tcPr/>
+                </a:tc>
+              </a:tr>
+            </a:tbl>
+          </a:graphicData>
+        </a:graphic>
+      </p:graphicFrame>
+      <p:sp>
+        <p:nvSpPr>
+          <p:cNvPr id="5" name="TextBox 4"/>
+          <p:cNvSpPr txBox="1"/>
+          <p:nvPr/>
+        </p:nvSpPr>
+        <p:spPr>
+          <a:xfrm>
+            <a:off x="685800" y="4892040"/>
+            <a:ext cx="10515600" cy="4389120"/>
+          </a:xfrm>
+          <a:prstGeom prst="rect">
+            <a:avLst/>
+          </a:prstGeom>
+          <a:noFill/>
+        </p:spPr>
+        <p:txBody>
+          <a:bodyPr wrap="square">
+            <a:spAutoFit/>
+          </a:bodyPr>
+          <a:lstStyle/>
+          <a:p>
+            <a:pPr>
+              <a:defRPr sz="1700">
+                <a:solidFill>
+                  <a:srgbClr val="111827"/>
+                </a:solidFill>
+              </a:defRPr>
+            </a:pPr>
+            <a:r>
+              <a:t>Artifact: runs/sec-lord-retrieved-evidence-gate-20260514/retrieved_evidence_prompts.jsonl</a:t>
+            </a:r>
+          </a:p>
+          <a:p>
+            <a:pPr>
+              <a:defRPr sz="1700">
+                <a:solidFill>
+                  <a:srgbClr val="111827"/>
+                </a:solidFill>
+              </a:defRPr>
+            </a:pPr>
+            <a:r>
+              <a:t>Report: reports/sec_lord_ds_lord/SEC_LORD_RETRIEVED_EVIDENCE_GATE_READY_20260514.md</a:t>
+            </a:r>
+          </a:p>
+        </p:txBody>
+      </p:sp>
+    </p:spTree>
+  </p:cSld>
+  <p:clrMapOvr>
+    <a:masterClrMapping/>
+  </p:clrMapOvr>
+</p:sld>
+</file>
+
+<file path=ppt/slides/slide7.xml><?xml version="1.0" encoding="utf-8"?>
 <p:sld xmlns:a="http://schemas.openxmlformats.org/drawingml/2006/main" xmlns:p="http://schemas.openxmlformats.org/presentationml/2006/main" xmlns:r="http://schemas.openxmlformats.org/officeDocument/2006/relationships">
   <p:cSld>
     <p:spTree>
@@ -5028,7 +5460,7 @@
 </p:sld>
 </file>
 
-<file path=ppt/slides/slide7.xml><?xml version="1.0" encoding="utf-8"?>
+<file path=ppt/slides/slide8.xml><?xml version="1.0" encoding="utf-8"?>
 <p:sld xmlns:a="http://schemas.openxmlformats.org/drawingml/2006/main" xmlns:p="http://schemas.openxmlformats.org/presentationml/2006/main" xmlns:r="http://schemas.openxmlformats.org/officeDocument/2006/relationships">
   <p:cSld>
     <p:spTree>
@@ -5471,7 +5903,7 @@
 </p:sld>
 </file>
 
-<file path=ppt/slides/slide8.xml><?xml version="1.0" encoding="utf-8"?>
+<file path=ppt/slides/slide9.xml><?xml version="1.0" encoding="utf-8"?>
 <p:sld xmlns:a="http://schemas.openxmlformats.org/drawingml/2006/main" xmlns:p="http://schemas.openxmlformats.org/presentationml/2006/main" xmlns:r="http://schemas.openxmlformats.org/officeDocument/2006/relationships">
   <p:cSld>
     <p:spTree>
@@ -5591,7 +6023,7 @@
               </a:defRPr>
             </a:pPr>
             <a:r>
-              <a:t>Implement retrieved-evidence prompt construction over the same CTI-MCQ set.</a:t>
+              <a:t>Run vanilla vs retrieved-evidence vs broad-seeded negative control.</a:t>
             </a:r>
           </a:p>
           <a:p>
@@ -5603,7 +6035,7 @@
               </a:defRPr>
             </a:pPr>
             <a:r>
-              <a:t>Run vanilla vs retrieved-evidence vs broad-seeded negative control.</a:t>
+              <a:t>Score with strict parser only.</a:t>
             </a:r>
           </a:p>
           <a:p>
@@ -5615,7 +6047,7 @@
               </a:defRPr>
             </a:pPr>
             <a:r>
-              <a:t>Score with strict parser only.</a:t>
+              <a:t>Pass requires retrieved evidence &gt;= vanilla +0.030 absolute and no worse invalid rate.</a:t>
             </a:r>
           </a:p>
           <a:p>

</xml_diff>